<commit_message>
fix(portfolio): remediate deck infographic visuals
</commit_message>
<xml_diff>
--- a/docs/portfolio/allura-bofa-principal-engineer/deck/Allura-Agentic-AI-Framework-Harness-Portfolio.pptx
+++ b/docs/portfolio/allura-bofa-principal-engineer/deck/Allura-Agentic-AI-Framework-Harness-Portfolio.pptx
@@ -2,22 +2,22 @@
 <file path=ppt/presentation.xml><?xml version="1.0" encoding="utf-8"?>
 <p:presentation xmlns:p="http://schemas.openxmlformats.org/presentationml/2006/main">
   <p:sldMasterIdLst>
-    <p:sldMasterId xmlns:r="http://schemas.openxmlformats.org/officeDocument/2006/relationships" id="2147483648" r:id="Rb53a85763cf24931"/>
+    <p:sldMasterId xmlns:r="http://schemas.openxmlformats.org/officeDocument/2006/relationships" id="2147483648" r:id="Rbad4a687acbd46ec"/>
   </p:sldMasterIdLst>
   <p:notesMasterIdLst>
-    <p:notesMasterId xmlns:r="http://schemas.openxmlformats.org/officeDocument/2006/relationships" r:id="R0a2a0cdd45b44a50"/>
+    <p:notesMasterId xmlns:r="http://schemas.openxmlformats.org/officeDocument/2006/relationships" r:id="R8383cbf6d7024f3e"/>
   </p:notesMasterIdLst>
   <p:sldIdLst>
-    <p:sldId xmlns:r="http://schemas.openxmlformats.org/officeDocument/2006/relationships" id="256" r:id="Rd68ed9673d414872"/>
-    <p:sldId xmlns:r="http://schemas.openxmlformats.org/officeDocument/2006/relationships" id="257" r:id="R199d91cb45264f60"/>
-    <p:sldId xmlns:r="http://schemas.openxmlformats.org/officeDocument/2006/relationships" id="258" r:id="Rdf62e7db10f4467d"/>
-    <p:sldId xmlns:r="http://schemas.openxmlformats.org/officeDocument/2006/relationships" id="259" r:id="R8b2cc913c9094980"/>
-    <p:sldId xmlns:r="http://schemas.openxmlformats.org/officeDocument/2006/relationships" id="260" r:id="R5b2b0e7c3a1e4ef1"/>
-    <p:sldId xmlns:r="http://schemas.openxmlformats.org/officeDocument/2006/relationships" id="261" r:id="R0336f14e66ec4e0d"/>
-    <p:sldId xmlns:r="http://schemas.openxmlformats.org/officeDocument/2006/relationships" id="262" r:id="Rd6b7cc43da5341fe"/>
-    <p:sldId xmlns:r="http://schemas.openxmlformats.org/officeDocument/2006/relationships" id="263" r:id="Rc5ceedc4604d4aca"/>
-    <p:sldId xmlns:r="http://schemas.openxmlformats.org/officeDocument/2006/relationships" id="264" r:id="Rea18dfc37818470b"/>
-    <p:sldId xmlns:r="http://schemas.openxmlformats.org/officeDocument/2006/relationships" id="265" r:id="R472e8e4641e14560"/>
+    <p:sldId xmlns:r="http://schemas.openxmlformats.org/officeDocument/2006/relationships" id="256" r:id="R89a07db129fc46ce"/>
+    <p:sldId xmlns:r="http://schemas.openxmlformats.org/officeDocument/2006/relationships" id="257" r:id="Ra45a577d7c8e4325"/>
+    <p:sldId xmlns:r="http://schemas.openxmlformats.org/officeDocument/2006/relationships" id="258" r:id="R10cbfb274a3d4095"/>
+    <p:sldId xmlns:r="http://schemas.openxmlformats.org/officeDocument/2006/relationships" id="259" r:id="R6d6b068fac9140f1"/>
+    <p:sldId xmlns:r="http://schemas.openxmlformats.org/officeDocument/2006/relationships" id="260" r:id="Rbe8a0d7ba97d490b"/>
+    <p:sldId xmlns:r="http://schemas.openxmlformats.org/officeDocument/2006/relationships" id="261" r:id="R817b20ea40ef4b34"/>
+    <p:sldId xmlns:r="http://schemas.openxmlformats.org/officeDocument/2006/relationships" id="262" r:id="Re6eb2bed4a34420c"/>
+    <p:sldId xmlns:r="http://schemas.openxmlformats.org/officeDocument/2006/relationships" id="263" r:id="Re33923c0fb5e45b8"/>
+    <p:sldId xmlns:r="http://schemas.openxmlformats.org/officeDocument/2006/relationships" id="264" r:id="Re165621d0e024327"/>
+    <p:sldId xmlns:r="http://schemas.openxmlformats.org/officeDocument/2006/relationships" id="265" r:id="Rb1a28499e333466f"/>
   </p:sldIdLst>
   <p:sldSz cx="12192000" cy="6858000"/>
   <p:notesSz cx="6858000" cy="9144000"/>
@@ -1379,7 +1379,7 @@
   </p:cSld>
   <p:clrMap bg1="lt1" tx1="dk1" bg2="lt2" tx2="dk2" accent1="accent1" accent2="accent2" accent3="accent3" accent4="accent4" accent5="accent5" accent6="accent6" hlink="hlink" folHlink="folHlink"/>
   <p:sldLayoutIdLst>
-    <p:sldLayoutId xmlns:r="http://schemas.openxmlformats.org/officeDocument/2006/relationships" id="2147483649" r:id="Rf846dcd3a90a48f1"/>
+    <p:sldLayoutId xmlns:r="http://schemas.openxmlformats.org/officeDocument/2006/relationships" id="2147483649" r:id="R489f57eb78dc4936"/>
   </p:sldLayoutIdLst>
   <p:txStyles>
     <p:titleStyle>
@@ -1934,7 +1934,7 @@
           <p:nvPr/>
         </p:nvPicPr>
         <p:blipFill>
-          <a:blip xmlns:r="http://schemas.openxmlformats.org/officeDocument/2006/relationships" xmlns:a="http://schemas.openxmlformats.org/drawingml/2006/main" r:embed="Rde5b2ded24bd468a"/>
+          <a:blip xmlns:r="http://schemas.openxmlformats.org/officeDocument/2006/relationships" xmlns:a="http://schemas.openxmlformats.org/drawingml/2006/main" r:embed="R92d57c525fda4f54"/>
           <a:stretch xmlns:a="http://schemas.openxmlformats.org/drawingml/2006/main"/>
         </p:blipFill>
         <p:spPr>
@@ -1952,7 +1952,7 @@
           <p:cNvPr id="2" name="eyebrow">
             <a:extLst xmlns:a="http://schemas.openxmlformats.org/drawingml/2006/main">
               <a:ext uri="{FF2B5EF4-FFF2-40B4-BE49-F238E27FC236}">
-                <a16:creationId xmlns:a16="http://schemas.microsoft.com/office/drawing/2014/main" id="{67DC8106-2547-4B0B-9CEC-B5DFAC03A9C3}"/>
+                <a16:creationId xmlns:a16="http://schemas.microsoft.com/office/drawing/2014/main" id="{58B3071C-8BC5-4367-83AD-E215D8B2F3E4}"/>
               </a:ext>
             </a:extLst>
           </p:cNvPr>
@@ -2002,7 +2002,7 @@
           <p:cNvPr id="3" name="slide-number">
             <a:extLst xmlns:a="http://schemas.openxmlformats.org/drawingml/2006/main">
               <a:ext uri="{FF2B5EF4-FFF2-40B4-BE49-F238E27FC236}">
-                <a16:creationId xmlns:a16="http://schemas.microsoft.com/office/drawing/2014/main" id="{FB0AA15B-1CF3-4A1E-AC24-554EDB33B3CA}"/>
+                <a16:creationId xmlns:a16="http://schemas.microsoft.com/office/drawing/2014/main" id="{8394B277-92DE-4C72-82A2-57DB34897B02}"/>
               </a:ext>
             </a:extLst>
           </p:cNvPr>
@@ -2052,7 +2052,7 @@
           <p:cNvPr id="4" name="top-rule">
             <a:extLst xmlns:a="http://schemas.openxmlformats.org/drawingml/2006/main">
               <a:ext uri="{FF2B5EF4-FFF2-40B4-BE49-F238E27FC236}">
-                <a16:creationId xmlns:a16="http://schemas.microsoft.com/office/drawing/2014/main" id="{757B4E48-9E57-4BEF-B59C-50EC11DEB09C}"/>
+                <a16:creationId xmlns:a16="http://schemas.microsoft.com/office/drawing/2014/main" id="{3132D840-7C5A-4201-9A3A-6CCEE9BD86BB}"/>
               </a:ext>
             </a:extLst>
           </p:cNvPr>
@@ -2083,7 +2083,7 @@
           <p:cNvPr id="5" name="title-panel">
             <a:extLst xmlns:a="http://schemas.openxmlformats.org/drawingml/2006/main">
               <a:ext uri="{FF2B5EF4-FFF2-40B4-BE49-F238E27FC236}">
-                <a16:creationId xmlns:a16="http://schemas.microsoft.com/office/drawing/2014/main" id="{52BF1CB5-DC57-43FA-B691-913DFC32B8D3}"/>
+                <a16:creationId xmlns:a16="http://schemas.microsoft.com/office/drawing/2014/main" id="{06A71656-D3CC-4157-B083-895E4EF1AA23}"/>
               </a:ext>
             </a:extLst>
           </p:cNvPr>
@@ -2118,7 +2118,7 @@
           <p:cNvPr id="6" name="kicker">
             <a:extLst xmlns:a="http://schemas.openxmlformats.org/drawingml/2006/main">
               <a:ext uri="{FF2B5EF4-FFF2-40B4-BE49-F238E27FC236}">
-                <a16:creationId xmlns:a16="http://schemas.microsoft.com/office/drawing/2014/main" id="{E5B6080B-4298-4E90-A335-6A3C838A4D24}"/>
+                <a16:creationId xmlns:a16="http://schemas.microsoft.com/office/drawing/2014/main" id="{D1B7F1D4-1030-4130-A019-0301E534E40C}"/>
               </a:ext>
             </a:extLst>
           </p:cNvPr>
@@ -2168,7 +2168,7 @@
           <p:cNvPr id="7" name="title">
             <a:extLst xmlns:a="http://schemas.openxmlformats.org/drawingml/2006/main">
               <a:ext uri="{FF2B5EF4-FFF2-40B4-BE49-F238E27FC236}">
-                <a16:creationId xmlns:a16="http://schemas.microsoft.com/office/drawing/2014/main" id="{93DADF7C-CADD-4B1E-BB44-6AC557B343B4}"/>
+                <a16:creationId xmlns:a16="http://schemas.microsoft.com/office/drawing/2014/main" id="{09CBA1CD-1554-4932-AB5B-E56FFA12BAEC}"/>
               </a:ext>
             </a:extLst>
           </p:cNvPr>
@@ -2235,7 +2235,7 @@
           <p:cNvPr id="8" name="subtitle">
             <a:extLst xmlns:a="http://schemas.openxmlformats.org/drawingml/2006/main">
               <a:ext uri="{FF2B5EF4-FFF2-40B4-BE49-F238E27FC236}">
-                <a16:creationId xmlns:a16="http://schemas.microsoft.com/office/drawing/2014/main" id="{5527080A-49FC-4841-B0AB-B47B2FBDCA8A}"/>
+                <a16:creationId xmlns:a16="http://schemas.microsoft.com/office/drawing/2014/main" id="{1B85482A-F014-4676-B822-67CE8857F000}"/>
               </a:ext>
             </a:extLst>
           </p:cNvPr>
@@ -2285,7 +2285,7 @@
           <p:cNvPr id="9" name="blue-module">
             <a:extLst xmlns:a="http://schemas.openxmlformats.org/drawingml/2006/main">
               <a:ext uri="{FF2B5EF4-FFF2-40B4-BE49-F238E27FC236}">
-                <a16:creationId xmlns:a16="http://schemas.microsoft.com/office/drawing/2014/main" id="{7918A4AC-8735-4B43-B55E-17FD391EFD66}"/>
+                <a16:creationId xmlns:a16="http://schemas.microsoft.com/office/drawing/2014/main" id="{AC9F75D1-9071-4E9D-8359-033EB39C31B3}"/>
               </a:ext>
             </a:extLst>
           </p:cNvPr>
@@ -2320,7 +2320,7 @@
           <p:cNvPr id="10" name="orange-module">
             <a:extLst xmlns:a="http://schemas.openxmlformats.org/drawingml/2006/main">
               <a:ext uri="{FF2B5EF4-FFF2-40B4-BE49-F238E27FC236}">
-                <a16:creationId xmlns:a16="http://schemas.microsoft.com/office/drawing/2014/main" id="{0AACAFDF-FACD-44B0-9E4E-00C58B815936}"/>
+                <a16:creationId xmlns:a16="http://schemas.microsoft.com/office/drawing/2014/main" id="{1AF8D434-D1A3-4D86-A475-387082BCFFE9}"/>
               </a:ext>
             </a:extLst>
           </p:cNvPr>
@@ -2353,7 +2353,7 @@
           <p:cNvPr id="11" name="green-module">
             <a:extLst xmlns:a="http://schemas.openxmlformats.org/drawingml/2006/main">
               <a:ext uri="{FF2B5EF4-FFF2-40B4-BE49-F238E27FC236}">
-                <a16:creationId xmlns:a16="http://schemas.microsoft.com/office/drawing/2014/main" id="{F75EF943-C0A0-41DF-9F16-C761E264714F}"/>
+                <a16:creationId xmlns:a16="http://schemas.microsoft.com/office/drawing/2014/main" id="{4BAD5A9D-C7F4-461B-A83B-C46989CBBF70}"/>
               </a:ext>
             </a:extLst>
           </p:cNvPr>
@@ -2388,7 +2388,7 @@
           <p:cNvPr id="12" name="role">
             <a:extLst xmlns:a="http://schemas.openxmlformats.org/drawingml/2006/main">
               <a:ext uri="{FF2B5EF4-FFF2-40B4-BE49-F238E27FC236}">
-                <a16:creationId xmlns:a16="http://schemas.microsoft.com/office/drawing/2014/main" id="{67DD0968-5A5B-472F-803A-265CE936C08C}"/>
+                <a16:creationId xmlns:a16="http://schemas.microsoft.com/office/drawing/2014/main" id="{B9DAAA57-9F1E-4192-A5A5-1129FA9B5D77}"/>
               </a:ext>
             </a:extLst>
           </p:cNvPr>
@@ -2438,7 +2438,7 @@
           <p:cNvPr id="13" name="disclaimer">
             <a:extLst xmlns:a="http://schemas.openxmlformats.org/drawingml/2006/main">
               <a:ext uri="{FF2B5EF4-FFF2-40B4-BE49-F238E27FC236}">
-                <a16:creationId xmlns:a16="http://schemas.microsoft.com/office/drawing/2014/main" id="{0E3247C2-EA5C-410F-AA2C-279EF8AE9A34}"/>
+                <a16:creationId xmlns:a16="http://schemas.microsoft.com/office/drawing/2014/main" id="{24B873E9-A91A-4EC0-9F47-0294D5DAE4A0}"/>
               </a:ext>
             </a:extLst>
           </p:cNvPr>
@@ -2486,7 +2486,7 @@
     </p:spTree>
     <p:extLst>
       <p:ext uri="{BB962C8B-B14F-4D97-AF65-F5344CB8AC3E}">
-        <p14:creationId xmlns:p14="http://schemas.microsoft.com/office/powerpoint/2010/main" val="1462650571"/>
+        <p14:creationId xmlns:p14="http://schemas.microsoft.com/office/powerpoint/2010/main" val="1628649512"/>
       </p:ext>
     </p:extLst>
   </p:cSld>
@@ -2521,7 +2521,7 @@
           <p:nvPr/>
         </p:nvPicPr>
         <p:blipFill>
-          <a:blip xmlns:r="http://schemas.openxmlformats.org/officeDocument/2006/relationships" xmlns:a="http://schemas.openxmlformats.org/drawingml/2006/main" r:embed="R884dbf21223e46e9"/>
+          <a:blip xmlns:r="http://schemas.openxmlformats.org/officeDocument/2006/relationships" xmlns:a="http://schemas.openxmlformats.org/drawingml/2006/main" r:embed="R16c7abb724474680"/>
           <a:stretch xmlns:a="http://schemas.openxmlformats.org/drawingml/2006/main"/>
         </p:blipFill>
         <p:spPr>
@@ -2539,7 +2539,7 @@
           <p:cNvPr id="2" name="eyebrow">
             <a:extLst xmlns:a="http://schemas.openxmlformats.org/drawingml/2006/main">
               <a:ext uri="{FF2B5EF4-FFF2-40B4-BE49-F238E27FC236}">
-                <a16:creationId xmlns:a16="http://schemas.microsoft.com/office/drawing/2014/main" id="{D18601BF-80D1-4182-A5BB-449FB9C72CDA}"/>
+                <a16:creationId xmlns:a16="http://schemas.microsoft.com/office/drawing/2014/main" id="{5323FB9F-2F19-406B-9876-F1246532CAF5}"/>
               </a:ext>
             </a:extLst>
           </p:cNvPr>
@@ -2589,7 +2589,7 @@
           <p:cNvPr id="3" name="slide-number">
             <a:extLst xmlns:a="http://schemas.openxmlformats.org/drawingml/2006/main">
               <a:ext uri="{FF2B5EF4-FFF2-40B4-BE49-F238E27FC236}">
-                <a16:creationId xmlns:a16="http://schemas.microsoft.com/office/drawing/2014/main" id="{47F6725B-C159-45ED-9F3C-3EFE5AB89840}"/>
+                <a16:creationId xmlns:a16="http://schemas.microsoft.com/office/drawing/2014/main" id="{F8764627-CBEA-4B0D-81BE-D32200FE6539}"/>
               </a:ext>
             </a:extLst>
           </p:cNvPr>
@@ -2639,7 +2639,7 @@
           <p:cNvPr id="4" name="top-rule">
             <a:extLst xmlns:a="http://schemas.openxmlformats.org/drawingml/2006/main">
               <a:ext uri="{FF2B5EF4-FFF2-40B4-BE49-F238E27FC236}">
-                <a16:creationId xmlns:a16="http://schemas.microsoft.com/office/drawing/2014/main" id="{F9A31F45-8154-4C4A-B4CB-B90C128B0369}"/>
+                <a16:creationId xmlns:a16="http://schemas.microsoft.com/office/drawing/2014/main" id="{E8964123-3417-4333-B4B3-067D462BD57B}"/>
               </a:ext>
             </a:extLst>
           </p:cNvPr>
@@ -2670,7 +2670,7 @@
           <p:cNvPr id="5" name="title">
             <a:extLst xmlns:a="http://schemas.openxmlformats.org/drawingml/2006/main">
               <a:ext uri="{FF2B5EF4-FFF2-40B4-BE49-F238E27FC236}">
-                <a16:creationId xmlns:a16="http://schemas.microsoft.com/office/drawing/2014/main" id="{4770CDE4-568B-4109-A902-852CAF2D60CA}"/>
+                <a16:creationId xmlns:a16="http://schemas.microsoft.com/office/drawing/2014/main" id="{8AC3CD3F-9907-4A42-B900-8C26CC73747E}"/>
               </a:ext>
             </a:extLst>
           </p:cNvPr>
@@ -2720,7 +2720,7 @@
           <p:cNvPr id="6" name="intro">
             <a:extLst xmlns:a="http://schemas.openxmlformats.org/drawingml/2006/main">
               <a:ext uri="{FF2B5EF4-FFF2-40B4-BE49-F238E27FC236}">
-                <a16:creationId xmlns:a16="http://schemas.microsoft.com/office/drawing/2014/main" id="{BFA6EAA6-5F51-4AE8-AC44-57C2709A2337}"/>
+                <a16:creationId xmlns:a16="http://schemas.microsoft.com/office/drawing/2014/main" id="{01AEF84E-546C-4643-B044-84D9E24BB909}"/>
               </a:ext>
             </a:extLst>
           </p:cNvPr>
@@ -2770,7 +2770,7 @@
           <p:cNvPr id="7" name="col-0">
             <a:extLst xmlns:a="http://schemas.openxmlformats.org/drawingml/2006/main">
               <a:ext uri="{FF2B5EF4-FFF2-40B4-BE49-F238E27FC236}">
-                <a16:creationId xmlns:a16="http://schemas.microsoft.com/office/drawing/2014/main" id="{1EB593CA-164E-44A2-A8CA-A2BCA600B042}"/>
+                <a16:creationId xmlns:a16="http://schemas.microsoft.com/office/drawing/2014/main" id="{BC925F83-A981-414E-9F45-2CA78999D403}"/>
               </a:ext>
             </a:extLst>
           </p:cNvPr>
@@ -2805,7 +2805,7 @@
           <p:cNvPr id="8" name="col-kicker-0">
             <a:extLst xmlns:a="http://schemas.openxmlformats.org/drawingml/2006/main">
               <a:ext uri="{FF2B5EF4-FFF2-40B4-BE49-F238E27FC236}">
-                <a16:creationId xmlns:a16="http://schemas.microsoft.com/office/drawing/2014/main" id="{558239B4-CDA3-4A5C-A209-3BF3D6519FC1}"/>
+                <a16:creationId xmlns:a16="http://schemas.microsoft.com/office/drawing/2014/main" id="{A86B0502-5D35-4B93-A270-787A191B8510}"/>
               </a:ext>
             </a:extLst>
           </p:cNvPr>
@@ -2855,7 +2855,7 @@
           <p:cNvPr id="9" name="dot-0-0">
             <a:extLst xmlns:a="http://schemas.openxmlformats.org/drawingml/2006/main">
               <a:ext uri="{FF2B5EF4-FFF2-40B4-BE49-F238E27FC236}">
-                <a16:creationId xmlns:a16="http://schemas.microsoft.com/office/drawing/2014/main" id="{B5573695-7A51-4B01-A7B5-D4DCEC5D54B7}"/>
+                <a16:creationId xmlns:a16="http://schemas.microsoft.com/office/drawing/2014/main" id="{382FD605-CB0C-42B5-AB91-7E69078BC261}"/>
               </a:ext>
             </a:extLst>
           </p:cNvPr>
@@ -2888,7 +2888,7 @@
           <p:cNvPr id="10" name="list-0-0">
             <a:extLst xmlns:a="http://schemas.openxmlformats.org/drawingml/2006/main">
               <a:ext uri="{FF2B5EF4-FFF2-40B4-BE49-F238E27FC236}">
-                <a16:creationId xmlns:a16="http://schemas.microsoft.com/office/drawing/2014/main" id="{D61C6675-E99D-4969-86DE-AD873D133EFC}"/>
+                <a16:creationId xmlns:a16="http://schemas.microsoft.com/office/drawing/2014/main" id="{6952BB55-6690-45A9-A469-9A22A78F8386}"/>
               </a:ext>
             </a:extLst>
           </p:cNvPr>
@@ -2938,7 +2938,7 @@
           <p:cNvPr id="11" name="dot-0-1">
             <a:extLst xmlns:a="http://schemas.openxmlformats.org/drawingml/2006/main">
               <a:ext uri="{FF2B5EF4-FFF2-40B4-BE49-F238E27FC236}">
-                <a16:creationId xmlns:a16="http://schemas.microsoft.com/office/drawing/2014/main" id="{5410B4ED-C03C-4FB0-A91C-2C587140F5EB}"/>
+                <a16:creationId xmlns:a16="http://schemas.microsoft.com/office/drawing/2014/main" id="{32894D24-E7A9-4E12-82D2-A4BA152A2BCA}"/>
               </a:ext>
             </a:extLst>
           </p:cNvPr>
@@ -2971,7 +2971,7 @@
           <p:cNvPr id="12" name="list-0-1">
             <a:extLst xmlns:a="http://schemas.openxmlformats.org/drawingml/2006/main">
               <a:ext uri="{FF2B5EF4-FFF2-40B4-BE49-F238E27FC236}">
-                <a16:creationId xmlns:a16="http://schemas.microsoft.com/office/drawing/2014/main" id="{8A87B614-B13B-49FF-AB26-F5BCDFD56472}"/>
+                <a16:creationId xmlns:a16="http://schemas.microsoft.com/office/drawing/2014/main" id="{87D259DF-66C5-4339-8A5A-770EA6E46711}"/>
               </a:ext>
             </a:extLst>
           </p:cNvPr>
@@ -3021,7 +3021,7 @@
           <p:cNvPr id="13" name="dot-0-2">
             <a:extLst xmlns:a="http://schemas.openxmlformats.org/drawingml/2006/main">
               <a:ext uri="{FF2B5EF4-FFF2-40B4-BE49-F238E27FC236}">
-                <a16:creationId xmlns:a16="http://schemas.microsoft.com/office/drawing/2014/main" id="{FDDF6F63-3AEA-4928-A724-542C4ADF95CA}"/>
+                <a16:creationId xmlns:a16="http://schemas.microsoft.com/office/drawing/2014/main" id="{A35228AC-95E7-40EE-A162-ED47C928D7E0}"/>
               </a:ext>
             </a:extLst>
           </p:cNvPr>
@@ -3054,7 +3054,7 @@
           <p:cNvPr id="14" name="list-0-2">
             <a:extLst xmlns:a="http://schemas.openxmlformats.org/drawingml/2006/main">
               <a:ext uri="{FF2B5EF4-FFF2-40B4-BE49-F238E27FC236}">
-                <a16:creationId xmlns:a16="http://schemas.microsoft.com/office/drawing/2014/main" id="{ACB5449C-6493-442A-BBE3-6D1D23D9E7B2}"/>
+                <a16:creationId xmlns:a16="http://schemas.microsoft.com/office/drawing/2014/main" id="{55CEB970-46FD-4C90-A413-517094906E16}"/>
               </a:ext>
             </a:extLst>
           </p:cNvPr>
@@ -3104,7 +3104,7 @@
           <p:cNvPr id="15" name="dot-0-3">
             <a:extLst xmlns:a="http://schemas.openxmlformats.org/drawingml/2006/main">
               <a:ext uri="{FF2B5EF4-FFF2-40B4-BE49-F238E27FC236}">
-                <a16:creationId xmlns:a16="http://schemas.microsoft.com/office/drawing/2014/main" id="{823C0385-3CB8-4397-8702-3C9700A341FE}"/>
+                <a16:creationId xmlns:a16="http://schemas.microsoft.com/office/drawing/2014/main" id="{B06DB4F0-7282-4686-AD57-A2F57DCD5697}"/>
               </a:ext>
             </a:extLst>
           </p:cNvPr>
@@ -3137,7 +3137,7 @@
           <p:cNvPr id="16" name="list-0-3">
             <a:extLst xmlns:a="http://schemas.openxmlformats.org/drawingml/2006/main">
               <a:ext uri="{FF2B5EF4-FFF2-40B4-BE49-F238E27FC236}">
-                <a16:creationId xmlns:a16="http://schemas.microsoft.com/office/drawing/2014/main" id="{A83E1A62-388E-491E-87E7-339FCDE4C7CC}"/>
+                <a16:creationId xmlns:a16="http://schemas.microsoft.com/office/drawing/2014/main" id="{804C02A4-0CD9-42C6-9BAF-AA93783821F2}"/>
               </a:ext>
             </a:extLst>
           </p:cNvPr>
@@ -3187,7 +3187,7 @@
           <p:cNvPr id="17" name="col-1">
             <a:extLst xmlns:a="http://schemas.openxmlformats.org/drawingml/2006/main">
               <a:ext uri="{FF2B5EF4-FFF2-40B4-BE49-F238E27FC236}">
-                <a16:creationId xmlns:a16="http://schemas.microsoft.com/office/drawing/2014/main" id="{223CB72C-7F12-49CD-909F-192A3108A1DD}"/>
+                <a16:creationId xmlns:a16="http://schemas.microsoft.com/office/drawing/2014/main" id="{90773D1A-94EF-4F67-86B6-716E32AD8DF5}"/>
               </a:ext>
             </a:extLst>
           </p:cNvPr>
@@ -3222,7 +3222,7 @@
           <p:cNvPr id="18" name="col-kicker-1">
             <a:extLst xmlns:a="http://schemas.openxmlformats.org/drawingml/2006/main">
               <a:ext uri="{FF2B5EF4-FFF2-40B4-BE49-F238E27FC236}">
-                <a16:creationId xmlns:a16="http://schemas.microsoft.com/office/drawing/2014/main" id="{09C9B0DB-96C0-4AC1-BE07-AB6C623CABB1}"/>
+                <a16:creationId xmlns:a16="http://schemas.microsoft.com/office/drawing/2014/main" id="{F3C8CB2F-20FA-44D0-BC1D-77765D27B1D3}"/>
               </a:ext>
             </a:extLst>
           </p:cNvPr>
@@ -3272,7 +3272,7 @@
           <p:cNvPr id="19" name="dot-1-0">
             <a:extLst xmlns:a="http://schemas.openxmlformats.org/drawingml/2006/main">
               <a:ext uri="{FF2B5EF4-FFF2-40B4-BE49-F238E27FC236}">
-                <a16:creationId xmlns:a16="http://schemas.microsoft.com/office/drawing/2014/main" id="{6F1C531D-287F-4154-A723-472BDB4FBBCA}"/>
+                <a16:creationId xmlns:a16="http://schemas.microsoft.com/office/drawing/2014/main" id="{F5E266C9-67CF-400B-A72E-5FFB04DB9922}"/>
               </a:ext>
             </a:extLst>
           </p:cNvPr>
@@ -3305,7 +3305,7 @@
           <p:cNvPr id="20" name="list-1-0">
             <a:extLst xmlns:a="http://schemas.openxmlformats.org/drawingml/2006/main">
               <a:ext uri="{FF2B5EF4-FFF2-40B4-BE49-F238E27FC236}">
-                <a16:creationId xmlns:a16="http://schemas.microsoft.com/office/drawing/2014/main" id="{A442879B-96E3-4585-B0F0-FF32E36B2630}"/>
+                <a16:creationId xmlns:a16="http://schemas.microsoft.com/office/drawing/2014/main" id="{AA51A6F5-F507-49C7-8F00-B7BF58933DE5}"/>
               </a:ext>
             </a:extLst>
           </p:cNvPr>
@@ -3355,7 +3355,7 @@
           <p:cNvPr id="21" name="dot-1-1">
             <a:extLst xmlns:a="http://schemas.openxmlformats.org/drawingml/2006/main">
               <a:ext uri="{FF2B5EF4-FFF2-40B4-BE49-F238E27FC236}">
-                <a16:creationId xmlns:a16="http://schemas.microsoft.com/office/drawing/2014/main" id="{C3886B2A-21E5-4967-80E5-93B5C8750599}"/>
+                <a16:creationId xmlns:a16="http://schemas.microsoft.com/office/drawing/2014/main" id="{170E8D05-19B6-4105-9762-53D2DAD53B2C}"/>
               </a:ext>
             </a:extLst>
           </p:cNvPr>
@@ -3388,7 +3388,7 @@
           <p:cNvPr id="22" name="list-1-1">
             <a:extLst xmlns:a="http://schemas.openxmlformats.org/drawingml/2006/main">
               <a:ext uri="{FF2B5EF4-FFF2-40B4-BE49-F238E27FC236}">
-                <a16:creationId xmlns:a16="http://schemas.microsoft.com/office/drawing/2014/main" id="{F00E637C-9B37-4ADB-9082-F9B4CCAE3784}"/>
+                <a16:creationId xmlns:a16="http://schemas.microsoft.com/office/drawing/2014/main" id="{FE8968F8-6A94-4337-B334-7D537AC71A8E}"/>
               </a:ext>
             </a:extLst>
           </p:cNvPr>
@@ -3438,7 +3438,7 @@
           <p:cNvPr id="23" name="dot-1-2">
             <a:extLst xmlns:a="http://schemas.openxmlformats.org/drawingml/2006/main">
               <a:ext uri="{FF2B5EF4-FFF2-40B4-BE49-F238E27FC236}">
-                <a16:creationId xmlns:a16="http://schemas.microsoft.com/office/drawing/2014/main" id="{A36A2B5F-A526-4562-8034-525A99DF7B79}"/>
+                <a16:creationId xmlns:a16="http://schemas.microsoft.com/office/drawing/2014/main" id="{96FEC05C-2F36-4FAA-AD1E-F2F9EB2824FC}"/>
               </a:ext>
             </a:extLst>
           </p:cNvPr>
@@ -3471,7 +3471,7 @@
           <p:cNvPr id="24" name="list-1-2">
             <a:extLst xmlns:a="http://schemas.openxmlformats.org/drawingml/2006/main">
               <a:ext uri="{FF2B5EF4-FFF2-40B4-BE49-F238E27FC236}">
-                <a16:creationId xmlns:a16="http://schemas.microsoft.com/office/drawing/2014/main" id="{360F6E27-3BA3-4927-B297-D7E47396A310}"/>
+                <a16:creationId xmlns:a16="http://schemas.microsoft.com/office/drawing/2014/main" id="{C9129397-C0CD-4D08-8497-674D3BD38DD6}"/>
               </a:ext>
             </a:extLst>
           </p:cNvPr>
@@ -3521,7 +3521,7 @@
           <p:cNvPr id="25" name="dot-1-3">
             <a:extLst xmlns:a="http://schemas.openxmlformats.org/drawingml/2006/main">
               <a:ext uri="{FF2B5EF4-FFF2-40B4-BE49-F238E27FC236}">
-                <a16:creationId xmlns:a16="http://schemas.microsoft.com/office/drawing/2014/main" id="{29A4D959-FBE4-4814-B8EC-07AC735ECB83}"/>
+                <a16:creationId xmlns:a16="http://schemas.microsoft.com/office/drawing/2014/main" id="{759DBAFB-DCB1-453B-9CE0-A5EEE2D49377}"/>
               </a:ext>
             </a:extLst>
           </p:cNvPr>
@@ -3554,7 +3554,7 @@
           <p:cNvPr id="26" name="list-1-3">
             <a:extLst xmlns:a="http://schemas.openxmlformats.org/drawingml/2006/main">
               <a:ext uri="{FF2B5EF4-FFF2-40B4-BE49-F238E27FC236}">
-                <a16:creationId xmlns:a16="http://schemas.microsoft.com/office/drawing/2014/main" id="{23465FC1-197D-44F1-B7FA-97FB762DCCE4}"/>
+                <a16:creationId xmlns:a16="http://schemas.microsoft.com/office/drawing/2014/main" id="{723BB293-1FFB-4946-B85F-CCD4363D0C09}"/>
               </a:ext>
             </a:extLst>
           </p:cNvPr>
@@ -3604,7 +3604,7 @@
           <p:cNvPr id="27" name="col-2">
             <a:extLst xmlns:a="http://schemas.openxmlformats.org/drawingml/2006/main">
               <a:ext uri="{FF2B5EF4-FFF2-40B4-BE49-F238E27FC236}">
-                <a16:creationId xmlns:a16="http://schemas.microsoft.com/office/drawing/2014/main" id="{7D1F1B09-91C1-461E-906B-D9DC65AE6355}"/>
+                <a16:creationId xmlns:a16="http://schemas.microsoft.com/office/drawing/2014/main" id="{65F8B59C-997E-4DBB-8AF4-436591F5DC4A}"/>
               </a:ext>
             </a:extLst>
           </p:cNvPr>
@@ -3639,7 +3639,7 @@
           <p:cNvPr id="28" name="col-kicker-2">
             <a:extLst xmlns:a="http://schemas.openxmlformats.org/drawingml/2006/main">
               <a:ext uri="{FF2B5EF4-FFF2-40B4-BE49-F238E27FC236}">
-                <a16:creationId xmlns:a16="http://schemas.microsoft.com/office/drawing/2014/main" id="{AA9A1CC5-8AC9-4842-A00B-70A3D0C8A6EC}"/>
+                <a16:creationId xmlns:a16="http://schemas.microsoft.com/office/drawing/2014/main" id="{B575E243-F7F2-4A30-B0F6-C5F9C901B06A}"/>
               </a:ext>
             </a:extLst>
           </p:cNvPr>
@@ -3689,7 +3689,7 @@
           <p:cNvPr id="29" name="dot-2-0">
             <a:extLst xmlns:a="http://schemas.openxmlformats.org/drawingml/2006/main">
               <a:ext uri="{FF2B5EF4-FFF2-40B4-BE49-F238E27FC236}">
-                <a16:creationId xmlns:a16="http://schemas.microsoft.com/office/drawing/2014/main" id="{C0BD8B00-A5FC-4CD6-9FAB-BDF9DE98C698}"/>
+                <a16:creationId xmlns:a16="http://schemas.microsoft.com/office/drawing/2014/main" id="{04C99844-AC6B-430F-91EA-8BD63E3EA1CA}"/>
               </a:ext>
             </a:extLst>
           </p:cNvPr>
@@ -3722,7 +3722,7 @@
           <p:cNvPr id="30" name="list-2-0">
             <a:extLst xmlns:a="http://schemas.openxmlformats.org/drawingml/2006/main">
               <a:ext uri="{FF2B5EF4-FFF2-40B4-BE49-F238E27FC236}">
-                <a16:creationId xmlns:a16="http://schemas.microsoft.com/office/drawing/2014/main" id="{FAE508CE-6D84-4F9D-AFD8-B0D4B8CAB64B}"/>
+                <a16:creationId xmlns:a16="http://schemas.microsoft.com/office/drawing/2014/main" id="{F6887F3C-240F-4B51-A5C5-3F3B2EFE0E45}"/>
               </a:ext>
             </a:extLst>
           </p:cNvPr>
@@ -3772,7 +3772,7 @@
           <p:cNvPr id="31" name="dot-2-1">
             <a:extLst xmlns:a="http://schemas.openxmlformats.org/drawingml/2006/main">
               <a:ext uri="{FF2B5EF4-FFF2-40B4-BE49-F238E27FC236}">
-                <a16:creationId xmlns:a16="http://schemas.microsoft.com/office/drawing/2014/main" id="{C2A19402-CCAF-4757-BFE2-65863324EA9C}"/>
+                <a16:creationId xmlns:a16="http://schemas.microsoft.com/office/drawing/2014/main" id="{B03A9FE6-8810-4021-BA03-CF06EE75C3F5}"/>
               </a:ext>
             </a:extLst>
           </p:cNvPr>
@@ -3805,7 +3805,7 @@
           <p:cNvPr id="32" name="list-2-1">
             <a:extLst xmlns:a="http://schemas.openxmlformats.org/drawingml/2006/main">
               <a:ext uri="{FF2B5EF4-FFF2-40B4-BE49-F238E27FC236}">
-                <a16:creationId xmlns:a16="http://schemas.microsoft.com/office/drawing/2014/main" id="{A8F9C625-0588-4B44-9C13-7298C338222F}"/>
+                <a16:creationId xmlns:a16="http://schemas.microsoft.com/office/drawing/2014/main" id="{E23CBBC6-4CFE-4D5D-A8A7-D572FB2E9096}"/>
               </a:ext>
             </a:extLst>
           </p:cNvPr>
@@ -3855,7 +3855,7 @@
           <p:cNvPr id="33" name="dot-2-2">
             <a:extLst xmlns:a="http://schemas.openxmlformats.org/drawingml/2006/main">
               <a:ext uri="{FF2B5EF4-FFF2-40B4-BE49-F238E27FC236}">
-                <a16:creationId xmlns:a16="http://schemas.microsoft.com/office/drawing/2014/main" id="{76D8F89B-CF73-4B28-8790-1AC81999C1C7}"/>
+                <a16:creationId xmlns:a16="http://schemas.microsoft.com/office/drawing/2014/main" id="{7375784B-E9E4-4A34-A81F-7E34A47F0F2E}"/>
               </a:ext>
             </a:extLst>
           </p:cNvPr>
@@ -3888,7 +3888,7 @@
           <p:cNvPr id="34" name="list-2-2">
             <a:extLst xmlns:a="http://schemas.openxmlformats.org/drawingml/2006/main">
               <a:ext uri="{FF2B5EF4-FFF2-40B4-BE49-F238E27FC236}">
-                <a16:creationId xmlns:a16="http://schemas.microsoft.com/office/drawing/2014/main" id="{9DDE07BC-D931-454B-A44D-69C53EA313A1}"/>
+                <a16:creationId xmlns:a16="http://schemas.microsoft.com/office/drawing/2014/main" id="{5003EE46-C203-484A-B924-B1B51337DADB}"/>
               </a:ext>
             </a:extLst>
           </p:cNvPr>
@@ -3938,7 +3938,7 @@
           <p:cNvPr id="35" name="dot-2-3">
             <a:extLst xmlns:a="http://schemas.openxmlformats.org/drawingml/2006/main">
               <a:ext uri="{FF2B5EF4-FFF2-40B4-BE49-F238E27FC236}">
-                <a16:creationId xmlns:a16="http://schemas.microsoft.com/office/drawing/2014/main" id="{4592B476-4A0E-4903-B722-CDB2ABF6E57C}"/>
+                <a16:creationId xmlns:a16="http://schemas.microsoft.com/office/drawing/2014/main" id="{B46AA4A3-6EF7-4F54-82C7-43649512B668}"/>
               </a:ext>
             </a:extLst>
           </p:cNvPr>
@@ -3971,7 +3971,7 @@
           <p:cNvPr id="36" name="list-2-3">
             <a:extLst xmlns:a="http://schemas.openxmlformats.org/drawingml/2006/main">
               <a:ext uri="{FF2B5EF4-FFF2-40B4-BE49-F238E27FC236}">
-                <a16:creationId xmlns:a16="http://schemas.microsoft.com/office/drawing/2014/main" id="{1EBF93D2-44F6-410E-9C06-CA5B95E23BE5}"/>
+                <a16:creationId xmlns:a16="http://schemas.microsoft.com/office/drawing/2014/main" id="{2B3A67FE-2AC4-4FD8-904D-EC8E23E3EF6F}"/>
               </a:ext>
             </a:extLst>
           </p:cNvPr>
@@ -4021,7 +4021,7 @@
           <p:cNvPr id="37" name="close">
             <a:extLst xmlns:a="http://schemas.openxmlformats.org/drawingml/2006/main">
               <a:ext uri="{FF2B5EF4-FFF2-40B4-BE49-F238E27FC236}">
-                <a16:creationId xmlns:a16="http://schemas.microsoft.com/office/drawing/2014/main" id="{3B87561B-A366-42CE-B80D-90196831AEF6}"/>
+                <a16:creationId xmlns:a16="http://schemas.microsoft.com/office/drawing/2014/main" id="{A41C1F54-8703-44E0-85DA-5DF26407DD9E}"/>
               </a:ext>
             </a:extLst>
           </p:cNvPr>
@@ -4069,7 +4069,7 @@
     </p:spTree>
     <p:extLst>
       <p:ext uri="{BB962C8B-B14F-4D97-AF65-F5344CB8AC3E}">
-        <p14:creationId xmlns:p14="http://schemas.microsoft.com/office/powerpoint/2010/main" val="548033667"/>
+        <p14:creationId xmlns:p14="http://schemas.microsoft.com/office/powerpoint/2010/main" val="852771008"/>
       </p:ext>
     </p:extLst>
   </p:cSld>
@@ -4104,7 +4104,7 @@
           <p:nvPr/>
         </p:nvPicPr>
         <p:blipFill>
-          <a:blip xmlns:r="http://schemas.openxmlformats.org/officeDocument/2006/relationships" xmlns:a="http://schemas.openxmlformats.org/drawingml/2006/main" r:embed="Rb26f5905ba484d6d"/>
+          <a:blip xmlns:r="http://schemas.openxmlformats.org/officeDocument/2006/relationships" xmlns:a="http://schemas.openxmlformats.org/drawingml/2006/main" r:embed="Rc2b04b90632343c4"/>
           <a:stretch xmlns:a="http://schemas.openxmlformats.org/drawingml/2006/main"/>
         </p:blipFill>
         <p:spPr>
@@ -4122,7 +4122,7 @@
           <p:cNvPr id="2" name="eyebrow">
             <a:extLst xmlns:a="http://schemas.openxmlformats.org/drawingml/2006/main">
               <a:ext uri="{FF2B5EF4-FFF2-40B4-BE49-F238E27FC236}">
-                <a16:creationId xmlns:a16="http://schemas.microsoft.com/office/drawing/2014/main" id="{94093D41-EA38-4C12-8432-D67885F80D08}"/>
+                <a16:creationId xmlns:a16="http://schemas.microsoft.com/office/drawing/2014/main" id="{0BED45CA-5EEB-461F-9BB6-ED32AAAB0566}"/>
               </a:ext>
             </a:extLst>
           </p:cNvPr>
@@ -4172,7 +4172,7 @@
           <p:cNvPr id="3" name="slide-number">
             <a:extLst xmlns:a="http://schemas.openxmlformats.org/drawingml/2006/main">
               <a:ext uri="{FF2B5EF4-FFF2-40B4-BE49-F238E27FC236}">
-                <a16:creationId xmlns:a16="http://schemas.microsoft.com/office/drawing/2014/main" id="{2F160426-54A7-46B0-BA9A-AE134E415D25}"/>
+                <a16:creationId xmlns:a16="http://schemas.microsoft.com/office/drawing/2014/main" id="{F4F12100-3890-4CEC-9307-EBDA69DC2B9D}"/>
               </a:ext>
             </a:extLst>
           </p:cNvPr>
@@ -4222,7 +4222,7 @@
           <p:cNvPr id="4" name="top-rule">
             <a:extLst xmlns:a="http://schemas.openxmlformats.org/drawingml/2006/main">
               <a:ext uri="{FF2B5EF4-FFF2-40B4-BE49-F238E27FC236}">
-                <a16:creationId xmlns:a16="http://schemas.microsoft.com/office/drawing/2014/main" id="{2268B1F6-F0A7-4E7A-81A4-4BA169271365}"/>
+                <a16:creationId xmlns:a16="http://schemas.microsoft.com/office/drawing/2014/main" id="{DFC44033-777E-49D0-B4E2-30E588886CDD}"/>
               </a:ext>
             </a:extLst>
           </p:cNvPr>
@@ -4253,7 +4253,7 @@
           <p:cNvPr id="5" name="title">
             <a:extLst xmlns:a="http://schemas.openxmlformats.org/drawingml/2006/main">
               <a:ext uri="{FF2B5EF4-FFF2-40B4-BE49-F238E27FC236}">
-                <a16:creationId xmlns:a16="http://schemas.microsoft.com/office/drawing/2014/main" id="{7161A473-9639-4A54-B01D-F571758B0097}"/>
+                <a16:creationId xmlns:a16="http://schemas.microsoft.com/office/drawing/2014/main" id="{641A4E01-9B5F-477A-8263-C718B5E99909}"/>
               </a:ext>
             </a:extLst>
           </p:cNvPr>
@@ -4303,7 +4303,7 @@
           <p:cNvPr id="6" name="intro">
             <a:extLst xmlns:a="http://schemas.openxmlformats.org/drawingml/2006/main">
               <a:ext uri="{FF2B5EF4-FFF2-40B4-BE49-F238E27FC236}">
-                <a16:creationId xmlns:a16="http://schemas.microsoft.com/office/drawing/2014/main" id="{0C856186-6740-43F0-9C2B-52927105AB66}"/>
+                <a16:creationId xmlns:a16="http://schemas.microsoft.com/office/drawing/2014/main" id="{B2954C4C-63E9-4A67-8B3D-C9FDDC9B4858}"/>
               </a:ext>
             </a:extLst>
           </p:cNvPr>
@@ -4353,7 +4353,7 @@
           <p:cNvPr id="7" name="theme-0">
             <a:extLst xmlns:a="http://schemas.openxmlformats.org/drawingml/2006/main">
               <a:ext uri="{FF2B5EF4-FFF2-40B4-BE49-F238E27FC236}">
-                <a16:creationId xmlns:a16="http://schemas.microsoft.com/office/drawing/2014/main" id="{BC220D07-1ABC-4E6C-9456-B4AD67E621DF}"/>
+                <a16:creationId xmlns:a16="http://schemas.microsoft.com/office/drawing/2014/main" id="{E83AA223-253F-44EB-890A-CEF05362226D}"/>
               </a:ext>
             </a:extLst>
           </p:cNvPr>
@@ -4388,7 +4388,7 @@
           <p:cNvPr id="8" name="theme-kicker-0">
             <a:extLst xmlns:a="http://schemas.openxmlformats.org/drawingml/2006/main">
               <a:ext uri="{FF2B5EF4-FFF2-40B4-BE49-F238E27FC236}">
-                <a16:creationId xmlns:a16="http://schemas.microsoft.com/office/drawing/2014/main" id="{4E464D74-29CA-4986-8D09-2AED82DB73AF}"/>
+                <a16:creationId xmlns:a16="http://schemas.microsoft.com/office/drawing/2014/main" id="{B351B246-2828-4414-BE8C-E89F0838A8C9}"/>
               </a:ext>
             </a:extLst>
           </p:cNvPr>
@@ -4438,7 +4438,7 @@
           <p:cNvPr id="9" name="theme-heading-0">
             <a:extLst xmlns:a="http://schemas.openxmlformats.org/drawingml/2006/main">
               <a:ext uri="{FF2B5EF4-FFF2-40B4-BE49-F238E27FC236}">
-                <a16:creationId xmlns:a16="http://schemas.microsoft.com/office/drawing/2014/main" id="{4B3585E0-6C70-4E40-BD2C-DCAD742A9BBB}"/>
+                <a16:creationId xmlns:a16="http://schemas.microsoft.com/office/drawing/2014/main" id="{689C8BA8-FE7E-4485-B0FE-224C9CC0C644}"/>
               </a:ext>
             </a:extLst>
           </p:cNvPr>
@@ -4488,7 +4488,7 @@
           <p:cNvPr id="10" name="theme-body-0">
             <a:extLst xmlns:a="http://schemas.openxmlformats.org/drawingml/2006/main">
               <a:ext uri="{FF2B5EF4-FFF2-40B4-BE49-F238E27FC236}">
-                <a16:creationId xmlns:a16="http://schemas.microsoft.com/office/drawing/2014/main" id="{0A70701B-F82C-425C-B06A-1750A264D62E}"/>
+                <a16:creationId xmlns:a16="http://schemas.microsoft.com/office/drawing/2014/main" id="{79FBB17F-12E4-48FC-8AD7-7E9714F7FAE0}"/>
               </a:ext>
             </a:extLst>
           </p:cNvPr>
@@ -4538,7 +4538,7 @@
           <p:cNvPr id="11" name="theme-1">
             <a:extLst xmlns:a="http://schemas.openxmlformats.org/drawingml/2006/main">
               <a:ext uri="{FF2B5EF4-FFF2-40B4-BE49-F238E27FC236}">
-                <a16:creationId xmlns:a16="http://schemas.microsoft.com/office/drawing/2014/main" id="{FD22DA92-8FA7-4F85-B98B-FF42CF47840B}"/>
+                <a16:creationId xmlns:a16="http://schemas.microsoft.com/office/drawing/2014/main" id="{E675C915-6F8F-433E-9D25-386D0D59E500}"/>
               </a:ext>
             </a:extLst>
           </p:cNvPr>
@@ -4573,7 +4573,7 @@
           <p:cNvPr id="12" name="theme-kicker-1">
             <a:extLst xmlns:a="http://schemas.openxmlformats.org/drawingml/2006/main">
               <a:ext uri="{FF2B5EF4-FFF2-40B4-BE49-F238E27FC236}">
-                <a16:creationId xmlns:a16="http://schemas.microsoft.com/office/drawing/2014/main" id="{3506A388-606E-4CD4-AB9B-408AB46487AB}"/>
+                <a16:creationId xmlns:a16="http://schemas.microsoft.com/office/drawing/2014/main" id="{B30EDEE3-F41F-4934-BD6D-78627D85D9D2}"/>
               </a:ext>
             </a:extLst>
           </p:cNvPr>
@@ -4623,7 +4623,7 @@
           <p:cNvPr id="13" name="theme-heading-1">
             <a:extLst xmlns:a="http://schemas.openxmlformats.org/drawingml/2006/main">
               <a:ext uri="{FF2B5EF4-FFF2-40B4-BE49-F238E27FC236}">
-                <a16:creationId xmlns:a16="http://schemas.microsoft.com/office/drawing/2014/main" id="{3640566D-2947-4E2A-B465-6FB0EDE1DF59}"/>
+                <a16:creationId xmlns:a16="http://schemas.microsoft.com/office/drawing/2014/main" id="{389C5B29-F439-4D23-AB90-D67968D9C472}"/>
               </a:ext>
             </a:extLst>
           </p:cNvPr>
@@ -4673,7 +4673,7 @@
           <p:cNvPr id="14" name="theme-body-1">
             <a:extLst xmlns:a="http://schemas.openxmlformats.org/drawingml/2006/main">
               <a:ext uri="{FF2B5EF4-FFF2-40B4-BE49-F238E27FC236}">
-                <a16:creationId xmlns:a16="http://schemas.microsoft.com/office/drawing/2014/main" id="{F15CD8DB-06C5-45E0-AB36-3095EC86856E}"/>
+                <a16:creationId xmlns:a16="http://schemas.microsoft.com/office/drawing/2014/main" id="{1E45F6AC-73C4-4D84-9AA7-7D162258013D}"/>
               </a:ext>
             </a:extLst>
           </p:cNvPr>
@@ -4723,7 +4723,7 @@
           <p:cNvPr id="15" name="theme-2">
             <a:extLst xmlns:a="http://schemas.openxmlformats.org/drawingml/2006/main">
               <a:ext uri="{FF2B5EF4-FFF2-40B4-BE49-F238E27FC236}">
-                <a16:creationId xmlns:a16="http://schemas.microsoft.com/office/drawing/2014/main" id="{5A4F3A72-EB34-497A-B65D-6B482B86A3D4}"/>
+                <a16:creationId xmlns:a16="http://schemas.microsoft.com/office/drawing/2014/main" id="{FB9012BE-7E32-4037-8452-B317C3BF8A0D}"/>
               </a:ext>
             </a:extLst>
           </p:cNvPr>
@@ -4758,7 +4758,7 @@
           <p:cNvPr id="16" name="theme-kicker-2">
             <a:extLst xmlns:a="http://schemas.openxmlformats.org/drawingml/2006/main">
               <a:ext uri="{FF2B5EF4-FFF2-40B4-BE49-F238E27FC236}">
-                <a16:creationId xmlns:a16="http://schemas.microsoft.com/office/drawing/2014/main" id="{71FE861E-2D2B-49C9-AD56-B946E6A4882E}"/>
+                <a16:creationId xmlns:a16="http://schemas.microsoft.com/office/drawing/2014/main" id="{7C12B8F0-0273-4E92-B748-D15D7CFD5092}"/>
               </a:ext>
             </a:extLst>
           </p:cNvPr>
@@ -4808,7 +4808,7 @@
           <p:cNvPr id="17" name="theme-heading-2">
             <a:extLst xmlns:a="http://schemas.openxmlformats.org/drawingml/2006/main">
               <a:ext uri="{FF2B5EF4-FFF2-40B4-BE49-F238E27FC236}">
-                <a16:creationId xmlns:a16="http://schemas.microsoft.com/office/drawing/2014/main" id="{4A353F06-BE65-4CC9-AD96-963052D19D72}"/>
+                <a16:creationId xmlns:a16="http://schemas.microsoft.com/office/drawing/2014/main" id="{520C5599-12E6-49A9-9CD4-FC7A4156C427}"/>
               </a:ext>
             </a:extLst>
           </p:cNvPr>
@@ -4858,7 +4858,7 @@
           <p:cNvPr id="18" name="theme-body-2">
             <a:extLst xmlns:a="http://schemas.openxmlformats.org/drawingml/2006/main">
               <a:ext uri="{FF2B5EF4-FFF2-40B4-BE49-F238E27FC236}">
-                <a16:creationId xmlns:a16="http://schemas.microsoft.com/office/drawing/2014/main" id="{2B3917FB-9FE1-4546-A9E8-DABEFC070F96}"/>
+                <a16:creationId xmlns:a16="http://schemas.microsoft.com/office/drawing/2014/main" id="{01C50796-4FD3-47CB-9E30-D265CA62EB9E}"/>
               </a:ext>
             </a:extLst>
           </p:cNvPr>
@@ -4908,7 +4908,7 @@
           <p:cNvPr id="19" name="theme-3">
             <a:extLst xmlns:a="http://schemas.openxmlformats.org/drawingml/2006/main">
               <a:ext uri="{FF2B5EF4-FFF2-40B4-BE49-F238E27FC236}">
-                <a16:creationId xmlns:a16="http://schemas.microsoft.com/office/drawing/2014/main" id="{17622553-8CE1-4A0C-B8F8-D127D824577D}"/>
+                <a16:creationId xmlns:a16="http://schemas.microsoft.com/office/drawing/2014/main" id="{951982CD-E454-48E7-A46C-D876983EE18F}"/>
               </a:ext>
             </a:extLst>
           </p:cNvPr>
@@ -4943,7 +4943,7 @@
           <p:cNvPr id="20" name="theme-kicker-3">
             <a:extLst xmlns:a="http://schemas.openxmlformats.org/drawingml/2006/main">
               <a:ext uri="{FF2B5EF4-FFF2-40B4-BE49-F238E27FC236}">
-                <a16:creationId xmlns:a16="http://schemas.microsoft.com/office/drawing/2014/main" id="{150C863F-8FCD-4CF6-8AEA-D19FB5157CF8}"/>
+                <a16:creationId xmlns:a16="http://schemas.microsoft.com/office/drawing/2014/main" id="{BC2892B5-AF4C-4F81-81D7-84EA3F1B56F7}"/>
               </a:ext>
             </a:extLst>
           </p:cNvPr>
@@ -4993,7 +4993,7 @@
           <p:cNvPr id="21" name="theme-heading-3">
             <a:extLst xmlns:a="http://schemas.openxmlformats.org/drawingml/2006/main">
               <a:ext uri="{FF2B5EF4-FFF2-40B4-BE49-F238E27FC236}">
-                <a16:creationId xmlns:a16="http://schemas.microsoft.com/office/drawing/2014/main" id="{3DACA27B-838E-4DD5-87A8-21723FCC947D}"/>
+                <a16:creationId xmlns:a16="http://schemas.microsoft.com/office/drawing/2014/main" id="{F979BA74-5745-42AC-AFCA-98C64F933EC8}"/>
               </a:ext>
             </a:extLst>
           </p:cNvPr>
@@ -5043,7 +5043,7 @@
           <p:cNvPr id="22" name="theme-body-3">
             <a:extLst xmlns:a="http://schemas.openxmlformats.org/drawingml/2006/main">
               <a:ext uri="{FF2B5EF4-FFF2-40B4-BE49-F238E27FC236}">
-                <a16:creationId xmlns:a16="http://schemas.microsoft.com/office/drawing/2014/main" id="{B844840A-A86E-4AE2-9306-31B41A8B21E9}"/>
+                <a16:creationId xmlns:a16="http://schemas.microsoft.com/office/drawing/2014/main" id="{A2807574-5B71-4481-B632-1F31F1C745B7}"/>
               </a:ext>
             </a:extLst>
           </p:cNvPr>
@@ -5093,7 +5093,7 @@
           <p:cNvPr id="23" name="close">
             <a:extLst xmlns:a="http://schemas.openxmlformats.org/drawingml/2006/main">
               <a:ext uri="{FF2B5EF4-FFF2-40B4-BE49-F238E27FC236}">
-                <a16:creationId xmlns:a16="http://schemas.microsoft.com/office/drawing/2014/main" id="{A89D924C-FE2D-4C7D-93FD-9DBB9AC354CA}"/>
+                <a16:creationId xmlns:a16="http://schemas.microsoft.com/office/drawing/2014/main" id="{F7E66286-6A1E-495F-AA32-001363352851}"/>
               </a:ext>
             </a:extLst>
           </p:cNvPr>
@@ -5141,7 +5141,7 @@
     </p:spTree>
     <p:extLst>
       <p:ext uri="{BB962C8B-B14F-4D97-AF65-F5344CB8AC3E}">
-        <p14:creationId xmlns:p14="http://schemas.microsoft.com/office/powerpoint/2010/main" val="1160158226"/>
+        <p14:creationId xmlns:p14="http://schemas.microsoft.com/office/powerpoint/2010/main" val="370188263"/>
       </p:ext>
     </p:extLst>
   </p:cSld>
@@ -5176,7 +5176,7 @@
           <p:nvPr/>
         </p:nvPicPr>
         <p:blipFill>
-          <a:blip xmlns:r="http://schemas.openxmlformats.org/officeDocument/2006/relationships" xmlns:a="http://schemas.openxmlformats.org/drawingml/2006/main" r:embed="Rc0b9cb19616f45f3"/>
+          <a:blip xmlns:r="http://schemas.openxmlformats.org/officeDocument/2006/relationships" xmlns:a="http://schemas.openxmlformats.org/drawingml/2006/main" r:embed="R897b8ea4b11a4fc2"/>
           <a:stretch xmlns:a="http://schemas.openxmlformats.org/drawingml/2006/main"/>
         </p:blipFill>
         <p:spPr>
@@ -5194,7 +5194,7 @@
           <p:cNvPr id="2" name="boundary">
             <a:extLst xmlns:a="http://schemas.openxmlformats.org/drawingml/2006/main">
               <a:ext uri="{FF2B5EF4-FFF2-40B4-BE49-F238E27FC236}">
-                <a16:creationId xmlns:a16="http://schemas.microsoft.com/office/drawing/2014/main" id="{5606BB53-0A9E-49B1-BDCC-0B57CC697873}"/>
+                <a16:creationId xmlns:a16="http://schemas.microsoft.com/office/drawing/2014/main" id="{16E001F9-AB85-4EC6-8B1F-68D939CBB2C4}"/>
               </a:ext>
             </a:extLst>
           </p:cNvPr>
@@ -5242,7 +5242,7 @@
     </p:spTree>
     <p:extLst>
       <p:ext uri="{BB962C8B-B14F-4D97-AF65-F5344CB8AC3E}">
-        <p14:creationId xmlns:p14="http://schemas.microsoft.com/office/powerpoint/2010/main" val="545457508"/>
+        <p14:creationId xmlns:p14="http://schemas.microsoft.com/office/powerpoint/2010/main" val="91896292"/>
       </p:ext>
     </p:extLst>
   </p:cSld>
@@ -5277,7 +5277,7 @@
           <p:nvPr/>
         </p:nvPicPr>
         <p:blipFill>
-          <a:blip xmlns:r="http://schemas.openxmlformats.org/officeDocument/2006/relationships" xmlns:a="http://schemas.openxmlformats.org/drawingml/2006/main" r:embed="Rf2d28c4e8edd4c0b"/>
+          <a:blip xmlns:r="http://schemas.openxmlformats.org/officeDocument/2006/relationships" xmlns:a="http://schemas.openxmlformats.org/drawingml/2006/main" r:embed="R9c2de19d7738413c"/>
           <a:stretch xmlns:a="http://schemas.openxmlformats.org/drawingml/2006/main"/>
         </p:blipFill>
         <p:spPr>
@@ -5295,7 +5295,7 @@
           <p:cNvPr id="2" name="boundary">
             <a:extLst xmlns:a="http://schemas.openxmlformats.org/drawingml/2006/main">
               <a:ext uri="{FF2B5EF4-FFF2-40B4-BE49-F238E27FC236}">
-                <a16:creationId xmlns:a16="http://schemas.microsoft.com/office/drawing/2014/main" id="{75E8D49E-562D-418F-A197-FD4ECBE9FD56}"/>
+                <a16:creationId xmlns:a16="http://schemas.microsoft.com/office/drawing/2014/main" id="{14F0D901-5B76-487B-A927-4C3EDD24878F}"/>
               </a:ext>
             </a:extLst>
           </p:cNvPr>
@@ -5343,7 +5343,7 @@
     </p:spTree>
     <p:extLst>
       <p:ext uri="{BB962C8B-B14F-4D97-AF65-F5344CB8AC3E}">
-        <p14:creationId xmlns:p14="http://schemas.microsoft.com/office/powerpoint/2010/main" val="849296558"/>
+        <p14:creationId xmlns:p14="http://schemas.microsoft.com/office/powerpoint/2010/main" val="783631483"/>
       </p:ext>
     </p:extLst>
   </p:cSld>
@@ -5378,7 +5378,7 @@
           <p:nvPr/>
         </p:nvPicPr>
         <p:blipFill>
-          <a:blip xmlns:r="http://schemas.openxmlformats.org/officeDocument/2006/relationships" xmlns:a="http://schemas.openxmlformats.org/drawingml/2006/main" r:embed="Rc92f9cbd81ef4b60"/>
+          <a:blip xmlns:r="http://schemas.openxmlformats.org/officeDocument/2006/relationships" xmlns:a="http://schemas.openxmlformats.org/drawingml/2006/main" r:embed="R9f8bb306c6154d11"/>
           <a:stretch xmlns:a="http://schemas.openxmlformats.org/drawingml/2006/main"/>
         </p:blipFill>
         <p:spPr>
@@ -5396,7 +5396,7 @@
           <p:cNvPr id="2" name="boundary">
             <a:extLst xmlns:a="http://schemas.openxmlformats.org/drawingml/2006/main">
               <a:ext uri="{FF2B5EF4-FFF2-40B4-BE49-F238E27FC236}">
-                <a16:creationId xmlns:a16="http://schemas.microsoft.com/office/drawing/2014/main" id="{192EB3F5-FE42-4A29-BDDD-6EDD31E72453}"/>
+                <a16:creationId xmlns:a16="http://schemas.microsoft.com/office/drawing/2014/main" id="{458FD5C8-3623-493C-82DA-23C3385FB810}"/>
               </a:ext>
             </a:extLst>
           </p:cNvPr>
@@ -5444,7 +5444,7 @@
     </p:spTree>
     <p:extLst>
       <p:ext uri="{BB962C8B-B14F-4D97-AF65-F5344CB8AC3E}">
-        <p14:creationId xmlns:p14="http://schemas.microsoft.com/office/powerpoint/2010/main" val="1386022016"/>
+        <p14:creationId xmlns:p14="http://schemas.microsoft.com/office/powerpoint/2010/main" val="240464459"/>
       </p:ext>
     </p:extLst>
   </p:cSld>
@@ -5479,7 +5479,7 @@
           <p:nvPr/>
         </p:nvPicPr>
         <p:blipFill>
-          <a:blip xmlns:r="http://schemas.openxmlformats.org/officeDocument/2006/relationships" xmlns:a="http://schemas.openxmlformats.org/drawingml/2006/main" r:embed="R4554ae313baa4055"/>
+          <a:blip xmlns:r="http://schemas.openxmlformats.org/officeDocument/2006/relationships" xmlns:a="http://schemas.openxmlformats.org/drawingml/2006/main" r:embed="R67f3edac2b9046ab"/>
           <a:stretch xmlns:a="http://schemas.openxmlformats.org/drawingml/2006/main"/>
         </p:blipFill>
         <p:spPr>
@@ -5497,7 +5497,7 @@
           <p:cNvPr id="2" name="boundary">
             <a:extLst xmlns:a="http://schemas.openxmlformats.org/drawingml/2006/main">
               <a:ext uri="{FF2B5EF4-FFF2-40B4-BE49-F238E27FC236}">
-                <a16:creationId xmlns:a16="http://schemas.microsoft.com/office/drawing/2014/main" id="{82CAAB2D-88A9-46B0-8860-815F9DB97370}"/>
+                <a16:creationId xmlns:a16="http://schemas.microsoft.com/office/drawing/2014/main" id="{0EE968D7-45BB-42F9-BB4C-E9C7EBC84764}"/>
               </a:ext>
             </a:extLst>
           </p:cNvPr>
@@ -5545,7 +5545,7 @@
     </p:spTree>
     <p:extLst>
       <p:ext uri="{BB962C8B-B14F-4D97-AF65-F5344CB8AC3E}">
-        <p14:creationId xmlns:p14="http://schemas.microsoft.com/office/powerpoint/2010/main" val="1254327636"/>
+        <p14:creationId xmlns:p14="http://schemas.microsoft.com/office/powerpoint/2010/main" val="977150261"/>
       </p:ext>
     </p:extLst>
   </p:cSld>
@@ -5580,7 +5580,7 @@
           <p:nvPr/>
         </p:nvPicPr>
         <p:blipFill>
-          <a:blip xmlns:r="http://schemas.openxmlformats.org/officeDocument/2006/relationships" xmlns:a="http://schemas.openxmlformats.org/drawingml/2006/main" r:embed="R890b85cc892c416a"/>
+          <a:blip xmlns:r="http://schemas.openxmlformats.org/officeDocument/2006/relationships" xmlns:a="http://schemas.openxmlformats.org/drawingml/2006/main" r:embed="R11822850a6bf4436"/>
           <a:stretch xmlns:a="http://schemas.openxmlformats.org/drawingml/2006/main"/>
         </p:blipFill>
         <p:spPr>
@@ -5598,7 +5598,7 @@
           <p:cNvPr id="2" name="boundary">
             <a:extLst xmlns:a="http://schemas.openxmlformats.org/drawingml/2006/main">
               <a:ext uri="{FF2B5EF4-FFF2-40B4-BE49-F238E27FC236}">
-                <a16:creationId xmlns:a16="http://schemas.microsoft.com/office/drawing/2014/main" id="{3D41CD04-F133-4CDA-96A2-A15573DC1967}"/>
+                <a16:creationId xmlns:a16="http://schemas.microsoft.com/office/drawing/2014/main" id="{9808C76B-9534-4A2A-ACAA-F92C89C54FFF}"/>
               </a:ext>
             </a:extLst>
           </p:cNvPr>
@@ -5646,7 +5646,7 @@
     </p:spTree>
     <p:extLst>
       <p:ext uri="{BB962C8B-B14F-4D97-AF65-F5344CB8AC3E}">
-        <p14:creationId xmlns:p14="http://schemas.microsoft.com/office/powerpoint/2010/main" val="76930617"/>
+        <p14:creationId xmlns:p14="http://schemas.microsoft.com/office/powerpoint/2010/main" val="317399372"/>
       </p:ext>
     </p:extLst>
   </p:cSld>
@@ -5681,7 +5681,7 @@
           <p:nvPr/>
         </p:nvPicPr>
         <p:blipFill>
-          <a:blip xmlns:r="http://schemas.openxmlformats.org/officeDocument/2006/relationships" xmlns:a="http://schemas.openxmlformats.org/drawingml/2006/main" r:embed="R2891d62cf7c14e24"/>
+          <a:blip xmlns:r="http://schemas.openxmlformats.org/officeDocument/2006/relationships" xmlns:a="http://schemas.openxmlformats.org/drawingml/2006/main" r:embed="R13cb8f0e15b34a73"/>
           <a:stretch xmlns:a="http://schemas.openxmlformats.org/drawingml/2006/main"/>
         </p:blipFill>
         <p:spPr>
@@ -5699,7 +5699,7 @@
           <p:cNvPr id="2" name="boundary">
             <a:extLst xmlns:a="http://schemas.openxmlformats.org/drawingml/2006/main">
               <a:ext uri="{FF2B5EF4-FFF2-40B4-BE49-F238E27FC236}">
-                <a16:creationId xmlns:a16="http://schemas.microsoft.com/office/drawing/2014/main" id="{E78DFA0A-C0CC-42EF-BAE1-D3271550A17A}"/>
+                <a16:creationId xmlns:a16="http://schemas.microsoft.com/office/drawing/2014/main" id="{661681A7-829F-4D3E-BA2C-E5E45C73C4E6}"/>
               </a:ext>
             </a:extLst>
           </p:cNvPr>
@@ -5747,7 +5747,7 @@
     </p:spTree>
     <p:extLst>
       <p:ext uri="{BB962C8B-B14F-4D97-AF65-F5344CB8AC3E}">
-        <p14:creationId xmlns:p14="http://schemas.microsoft.com/office/powerpoint/2010/main" val="281946301"/>
+        <p14:creationId xmlns:p14="http://schemas.microsoft.com/office/powerpoint/2010/main" val="1506400993"/>
       </p:ext>
     </p:extLst>
   </p:cSld>
@@ -5782,7 +5782,7 @@
           <p:nvPr/>
         </p:nvPicPr>
         <p:blipFill>
-          <a:blip xmlns:r="http://schemas.openxmlformats.org/officeDocument/2006/relationships" xmlns:a="http://schemas.openxmlformats.org/drawingml/2006/main" r:embed="Re4d38dbc9a294c72"/>
+          <a:blip xmlns:r="http://schemas.openxmlformats.org/officeDocument/2006/relationships" xmlns:a="http://schemas.openxmlformats.org/drawingml/2006/main" r:embed="R3352189a353b4fef"/>
           <a:stretch xmlns:a="http://schemas.openxmlformats.org/drawingml/2006/main"/>
         </p:blipFill>
         <p:spPr>
@@ -5800,7 +5800,7 @@
           <p:cNvPr id="2" name="eyebrow">
             <a:extLst xmlns:a="http://schemas.openxmlformats.org/drawingml/2006/main">
               <a:ext uri="{FF2B5EF4-FFF2-40B4-BE49-F238E27FC236}">
-                <a16:creationId xmlns:a16="http://schemas.microsoft.com/office/drawing/2014/main" id="{D3A53F21-30FC-4B6F-A5C4-9E8C0F33DB3C}"/>
+                <a16:creationId xmlns:a16="http://schemas.microsoft.com/office/drawing/2014/main" id="{BB689BA1-D598-49BD-A5C9-18D522222092}"/>
               </a:ext>
             </a:extLst>
           </p:cNvPr>
@@ -5850,7 +5850,7 @@
           <p:cNvPr id="3" name="slide-number">
             <a:extLst xmlns:a="http://schemas.openxmlformats.org/drawingml/2006/main">
               <a:ext uri="{FF2B5EF4-FFF2-40B4-BE49-F238E27FC236}">
-                <a16:creationId xmlns:a16="http://schemas.microsoft.com/office/drawing/2014/main" id="{C3744FCF-58A1-4A22-ACA4-47B8154F5115}"/>
+                <a16:creationId xmlns:a16="http://schemas.microsoft.com/office/drawing/2014/main" id="{01ED19D9-677A-40CA-A324-8297AACFF517}"/>
               </a:ext>
             </a:extLst>
           </p:cNvPr>
@@ -5900,7 +5900,7 @@
           <p:cNvPr id="4" name="top-rule">
             <a:extLst xmlns:a="http://schemas.openxmlformats.org/drawingml/2006/main">
               <a:ext uri="{FF2B5EF4-FFF2-40B4-BE49-F238E27FC236}">
-                <a16:creationId xmlns:a16="http://schemas.microsoft.com/office/drawing/2014/main" id="{80BC392D-48D6-498C-BE16-A5B09E52799B}"/>
+                <a16:creationId xmlns:a16="http://schemas.microsoft.com/office/drawing/2014/main" id="{1BBF248F-9251-4869-B68F-67F63BBB982F}"/>
               </a:ext>
             </a:extLst>
           </p:cNvPr>
@@ -5931,7 +5931,7 @@
           <p:cNvPr id="5" name="title">
             <a:extLst xmlns:a="http://schemas.openxmlformats.org/drawingml/2006/main">
               <a:ext uri="{FF2B5EF4-FFF2-40B4-BE49-F238E27FC236}">
-                <a16:creationId xmlns:a16="http://schemas.microsoft.com/office/drawing/2014/main" id="{86727583-4F3D-4D47-91E9-B11C4E3943B7}"/>
+                <a16:creationId xmlns:a16="http://schemas.microsoft.com/office/drawing/2014/main" id="{4586B0AD-365F-416A-8BBA-69FC34187147}"/>
               </a:ext>
             </a:extLst>
           </p:cNvPr>
@@ -5981,7 +5981,7 @@
           <p:cNvPr id="6" name="intro">
             <a:extLst xmlns:a="http://schemas.openxmlformats.org/drawingml/2006/main">
               <a:ext uri="{FF2B5EF4-FFF2-40B4-BE49-F238E27FC236}">
-                <a16:creationId xmlns:a16="http://schemas.microsoft.com/office/drawing/2014/main" id="{FB913DAA-5F83-48EA-8011-04186C4BB823}"/>
+                <a16:creationId xmlns:a16="http://schemas.microsoft.com/office/drawing/2014/main" id="{2182972D-6955-48FE-9A59-05BAF3DF4269}"/>
               </a:ext>
             </a:extLst>
           </p:cNvPr>
@@ -6031,7 +6031,7 @@
           <p:cNvPr id="7" name="screenshot-frame">
             <a:extLst xmlns:a="http://schemas.openxmlformats.org/drawingml/2006/main">
               <a:ext uri="{FF2B5EF4-FFF2-40B4-BE49-F238E27FC236}">
-                <a16:creationId xmlns:a16="http://schemas.microsoft.com/office/drawing/2014/main" id="{C2FB7DDA-7150-406A-9009-3F30C4939BAA}"/>
+                <a16:creationId xmlns:a16="http://schemas.microsoft.com/office/drawing/2014/main" id="{ADFAD29A-6B0B-494A-97ED-F2CDC5BE378E}"/>
               </a:ext>
             </a:extLst>
           </p:cNvPr>
@@ -6070,13 +6070,13 @@
           <p:nvPr/>
         </p:nvPicPr>
         <p:blipFill>
-          <a:blip xmlns:r="http://schemas.openxmlformats.org/officeDocument/2006/relationships" xmlns:a="http://schemas.openxmlformats.org/drawingml/2006/main" r:embed="R73e0dde858444652"/>
+          <a:blip xmlns:r="http://schemas.openxmlformats.org/officeDocument/2006/relationships" xmlns:a="http://schemas.openxmlformats.org/drawingml/2006/main" r:embed="R784a7829153f4101"/>
           <a:stretch xmlns:a="http://schemas.openxmlformats.org/drawingml/2006/main"/>
         </p:blipFill>
         <p:spPr>
           <a:xfrm xmlns:a="http://schemas.openxmlformats.org/drawingml/2006/main">
-            <a:off x="1244130" y="2352675"/>
-            <a:ext cx="5207941" cy="3295650"/>
+            <a:off x="2071170" y="2352675"/>
+            <a:ext cx="3553860" cy="3295650"/>
           </a:xfrm>
           <a:prstGeom xmlns:a="http://schemas.openxmlformats.org/drawingml/2006/main" prst="rect">
             <a:avLst/>
@@ -6088,7 +6088,7 @@
           <p:cNvPr id="9" name="metric-0">
             <a:extLst xmlns:a="http://schemas.openxmlformats.org/drawingml/2006/main">
               <a:ext uri="{FF2B5EF4-FFF2-40B4-BE49-F238E27FC236}">
-                <a16:creationId xmlns:a16="http://schemas.microsoft.com/office/drawing/2014/main" id="{5BFAA5F7-F905-4529-8536-199C44E214A2}"/>
+                <a16:creationId xmlns:a16="http://schemas.microsoft.com/office/drawing/2014/main" id="{A0257A01-FC79-4F42-AA3D-64ECA8D6F70C}"/>
               </a:ext>
             </a:extLst>
           </p:cNvPr>
@@ -6138,7 +6138,7 @@
           <p:cNvPr id="10" name="metric-label-0">
             <a:extLst xmlns:a="http://schemas.openxmlformats.org/drawingml/2006/main">
               <a:ext uri="{FF2B5EF4-FFF2-40B4-BE49-F238E27FC236}">
-                <a16:creationId xmlns:a16="http://schemas.microsoft.com/office/drawing/2014/main" id="{5B989D63-D017-4CCF-B387-34FAF2CF6F0D}"/>
+                <a16:creationId xmlns:a16="http://schemas.microsoft.com/office/drawing/2014/main" id="{2A63A7D4-8F8C-49CD-BC5F-2C50AE494723}"/>
               </a:ext>
             </a:extLst>
           </p:cNvPr>
@@ -6188,7 +6188,7 @@
           <p:cNvPr id="11" name="metric-rule-0">
             <a:extLst xmlns:a="http://schemas.openxmlformats.org/drawingml/2006/main">
               <a:ext uri="{FF2B5EF4-FFF2-40B4-BE49-F238E27FC236}">
-                <a16:creationId xmlns:a16="http://schemas.microsoft.com/office/drawing/2014/main" id="{6F5FAD27-2872-4AC5-BA27-D332EB88400E}"/>
+                <a16:creationId xmlns:a16="http://schemas.microsoft.com/office/drawing/2014/main" id="{1FE10971-2FC2-4A4F-BAE9-2F8372387CF2}"/>
               </a:ext>
             </a:extLst>
           </p:cNvPr>
@@ -6219,7 +6219,7 @@
           <p:cNvPr id="12" name="metric-1">
             <a:extLst xmlns:a="http://schemas.openxmlformats.org/drawingml/2006/main">
               <a:ext uri="{FF2B5EF4-FFF2-40B4-BE49-F238E27FC236}">
-                <a16:creationId xmlns:a16="http://schemas.microsoft.com/office/drawing/2014/main" id="{74255A44-D180-4A41-B85D-D2B776482556}"/>
+                <a16:creationId xmlns:a16="http://schemas.microsoft.com/office/drawing/2014/main" id="{35734923-E688-4A08-AEBF-1C269B2B6142}"/>
               </a:ext>
             </a:extLst>
           </p:cNvPr>
@@ -6269,7 +6269,7 @@
           <p:cNvPr id="13" name="metric-label-1">
             <a:extLst xmlns:a="http://schemas.openxmlformats.org/drawingml/2006/main">
               <a:ext uri="{FF2B5EF4-FFF2-40B4-BE49-F238E27FC236}">
-                <a16:creationId xmlns:a16="http://schemas.microsoft.com/office/drawing/2014/main" id="{B650AF86-329D-423C-92F2-237749DDF30D}"/>
+                <a16:creationId xmlns:a16="http://schemas.microsoft.com/office/drawing/2014/main" id="{B0277DED-AC63-4539-8315-EE4426060475}"/>
               </a:ext>
             </a:extLst>
           </p:cNvPr>
@@ -6319,7 +6319,7 @@
           <p:cNvPr id="14" name="metric-rule-1">
             <a:extLst xmlns:a="http://schemas.openxmlformats.org/drawingml/2006/main">
               <a:ext uri="{FF2B5EF4-FFF2-40B4-BE49-F238E27FC236}">
-                <a16:creationId xmlns:a16="http://schemas.microsoft.com/office/drawing/2014/main" id="{19646961-5FCD-414A-8A26-7D33666B6204}"/>
+                <a16:creationId xmlns:a16="http://schemas.microsoft.com/office/drawing/2014/main" id="{E6F107A8-AEB8-4791-9CE4-2D50E8480F1B}"/>
               </a:ext>
             </a:extLst>
           </p:cNvPr>
@@ -6350,7 +6350,7 @@
           <p:cNvPr id="15" name="metric-2">
             <a:extLst xmlns:a="http://schemas.openxmlformats.org/drawingml/2006/main">
               <a:ext uri="{FF2B5EF4-FFF2-40B4-BE49-F238E27FC236}">
-                <a16:creationId xmlns:a16="http://schemas.microsoft.com/office/drawing/2014/main" id="{E6748879-3E50-4391-8427-202B955BB5DC}"/>
+                <a16:creationId xmlns:a16="http://schemas.microsoft.com/office/drawing/2014/main" id="{DFD6143B-F4EA-4342-86E4-E832A551BD87}"/>
               </a:ext>
             </a:extLst>
           </p:cNvPr>
@@ -6400,7 +6400,7 @@
           <p:cNvPr id="16" name="metric-label-2">
             <a:extLst xmlns:a="http://schemas.openxmlformats.org/drawingml/2006/main">
               <a:ext uri="{FF2B5EF4-FFF2-40B4-BE49-F238E27FC236}">
-                <a16:creationId xmlns:a16="http://schemas.microsoft.com/office/drawing/2014/main" id="{6B90A50E-2C07-4CBD-B420-149AE865A4B2}"/>
+                <a16:creationId xmlns:a16="http://schemas.microsoft.com/office/drawing/2014/main" id="{BAA4F343-3DF6-4AF7-B558-50D7802F780A}"/>
               </a:ext>
             </a:extLst>
           </p:cNvPr>
@@ -6450,7 +6450,7 @@
           <p:cNvPr id="17" name="metric-rule-2">
             <a:extLst xmlns:a="http://schemas.openxmlformats.org/drawingml/2006/main">
               <a:ext uri="{FF2B5EF4-FFF2-40B4-BE49-F238E27FC236}">
-                <a16:creationId xmlns:a16="http://schemas.microsoft.com/office/drawing/2014/main" id="{21E79CC2-C34D-41E1-9A74-1C5167F3C4F3}"/>
+                <a16:creationId xmlns:a16="http://schemas.microsoft.com/office/drawing/2014/main" id="{D5975C17-438F-4A7A-8D73-B4C481C324DA}"/>
               </a:ext>
             </a:extLst>
           </p:cNvPr>
@@ -6481,7 +6481,7 @@
           <p:cNvPr id="18" name="boundary">
             <a:extLst xmlns:a="http://schemas.openxmlformats.org/drawingml/2006/main">
               <a:ext uri="{FF2B5EF4-FFF2-40B4-BE49-F238E27FC236}">
-                <a16:creationId xmlns:a16="http://schemas.microsoft.com/office/drawing/2014/main" id="{B5BE8168-3A28-4BD3-AF9D-7911AEB4704A}"/>
+                <a16:creationId xmlns:a16="http://schemas.microsoft.com/office/drawing/2014/main" id="{680E19DB-55D9-42F7-ACFD-4296BB42B157}"/>
               </a:ext>
             </a:extLst>
           </p:cNvPr>
@@ -6529,7 +6529,7 @@
     </p:spTree>
     <p:extLst>
       <p:ext uri="{BB962C8B-B14F-4D97-AF65-F5344CB8AC3E}">
-        <p14:creationId xmlns:p14="http://schemas.microsoft.com/office/powerpoint/2010/main" val="1906873803"/>
+        <p14:creationId xmlns:p14="http://schemas.microsoft.com/office/powerpoint/2010/main" val="194873729"/>
       </p:ext>
     </p:extLst>
   </p:cSld>

</xml_diff>